<commit_message>
feat: match colors to loop
</commit_message>
<xml_diff>
--- a/docs/figures/pptx/branches.pptx
+++ b/docs/figures/pptx/branches.pptx
@@ -5799,7 +5799,7 @@
             <a:r>
               <a:rPr lang="en-US" b="1" dirty="0">
                 <a:solidFill>
-                  <a:schemeClr val="accent1"/>
+                  <a:schemeClr val="accent4"/>
                 </a:solidFill>
                 <a:latin typeface="Source Sans Pro" panose="020B0503030403020204" pitchFamily="34" charset="0"/>
                 <a:ea typeface="Source Sans Pro" panose="020B0503030403020204" pitchFamily="34" charset="0"/>
@@ -5841,7 +5841,9 @@
             <a:r>
               <a:rPr lang="en-US" b="1" dirty="0">
                 <a:solidFill>
-                  <a:schemeClr val="accent5"/>
+                  <a:schemeClr val="accent1">
+                    <a:lumMod val="75000"/>
+                  </a:schemeClr>
                 </a:solidFill>
                 <a:latin typeface="Source Sans Pro" panose="020B0503030403020204" pitchFamily="34" charset="0"/>
                 <a:ea typeface="Source Sans Pro" panose="020B0503030403020204" pitchFamily="34" charset="0"/>
@@ -5883,7 +5885,7 @@
             <a:r>
               <a:rPr lang="en-US" b="1" dirty="0">
                 <a:solidFill>
-                  <a:schemeClr val="accent4"/>
+                  <a:schemeClr val="accent5"/>
                 </a:solidFill>
                 <a:latin typeface="Source Sans Pro" panose="020B0503030403020204" pitchFamily="34" charset="0"/>
                 <a:ea typeface="Source Sans Pro" panose="020B0503030403020204" pitchFamily="34" charset="0"/>
@@ -5911,8 +5913,8 @@
         </p:nvCxnSpPr>
         <p:spPr>
           <a:xfrm>
-            <a:off x="1134838" y="537757"/>
-            <a:ext cx="6033989" cy="0"/>
+            <a:off x="1136378" y="538527"/>
+            <a:ext cx="6032449" cy="0"/>
           </a:xfrm>
           <a:prstGeom prst="line">
             <a:avLst/>
@@ -5956,8 +5958,8 @@
         </p:nvCxnSpPr>
         <p:spPr>
           <a:xfrm>
-            <a:off x="1782482" y="1071111"/>
-            <a:ext cx="1657233" cy="0"/>
+            <a:off x="1784022" y="1071881"/>
+            <a:ext cx="1655694" cy="0"/>
           </a:xfrm>
           <a:prstGeom prst="line">
             <a:avLst/>
@@ -6001,8 +6003,8 @@
         </p:nvCxnSpPr>
         <p:spPr>
           <a:xfrm>
-            <a:off x="2309476" y="1604465"/>
-            <a:ext cx="241279" cy="0"/>
+            <a:off x="2311017" y="1605236"/>
+            <a:ext cx="239739" cy="0"/>
           </a:xfrm>
           <a:prstGeom prst="line">
             <a:avLst/>
@@ -6046,8 +6048,8 @@
         </p:nvCxnSpPr>
         <p:spPr>
           <a:xfrm>
-            <a:off x="2741239" y="1604465"/>
-            <a:ext cx="241279" cy="0"/>
+            <a:off x="2742780" y="1605236"/>
+            <a:ext cx="239739" cy="0"/>
           </a:xfrm>
           <a:prstGeom prst="line">
             <a:avLst/>
@@ -6090,8 +6092,8 @@
         </p:nvCxnSpPr>
         <p:spPr>
           <a:xfrm>
-            <a:off x="1134838" y="537757"/>
-            <a:ext cx="457161" cy="533354"/>
+            <a:off x="1136378" y="538527"/>
+            <a:ext cx="455620" cy="533354"/>
           </a:xfrm>
           <a:prstGeom prst="curvedConnector3">
             <a:avLst/>
@@ -6135,8 +6137,8 @@
         </p:nvCxnSpPr>
         <p:spPr>
           <a:xfrm>
-            <a:off x="1782482" y="1071111"/>
-            <a:ext cx="336511" cy="533354"/>
+            <a:off x="1784022" y="1071881"/>
+            <a:ext cx="334971" cy="533355"/>
           </a:xfrm>
           <a:prstGeom prst="curvedConnector3">
             <a:avLst>
@@ -6182,8 +6184,8 @@
         </p:nvCxnSpPr>
         <p:spPr>
           <a:xfrm flipV="1">
-            <a:off x="3173003" y="1071111"/>
-            <a:ext cx="266713" cy="533354"/>
+            <a:off x="3174543" y="1071881"/>
+            <a:ext cx="265173" cy="533355"/>
           </a:xfrm>
           <a:prstGeom prst="curvedConnector3">
             <a:avLst>
@@ -6229,8 +6231,8 @@
         </p:nvCxnSpPr>
         <p:spPr>
           <a:xfrm>
-            <a:off x="4894718" y="1071111"/>
-            <a:ext cx="1657233" cy="0"/>
+            <a:off x="4896259" y="1071881"/>
+            <a:ext cx="1655693" cy="0"/>
           </a:xfrm>
           <a:prstGeom prst="line">
             <a:avLst/>
@@ -6274,8 +6276,8 @@
         </p:nvCxnSpPr>
         <p:spPr>
           <a:xfrm>
-            <a:off x="5421713" y="1604465"/>
-            <a:ext cx="241279" cy="0"/>
+            <a:off x="5423253" y="1605236"/>
+            <a:ext cx="239739" cy="0"/>
           </a:xfrm>
           <a:prstGeom prst="line">
             <a:avLst/>
@@ -6319,8 +6321,8 @@
         </p:nvCxnSpPr>
         <p:spPr>
           <a:xfrm>
-            <a:off x="5853476" y="1604465"/>
-            <a:ext cx="241279" cy="0"/>
+            <a:off x="5855016" y="1605236"/>
+            <a:ext cx="239739" cy="0"/>
           </a:xfrm>
           <a:prstGeom prst="line">
             <a:avLst/>
@@ -6364,8 +6366,8 @@
         </p:nvCxnSpPr>
         <p:spPr>
           <a:xfrm flipV="1">
-            <a:off x="6742436" y="537757"/>
-            <a:ext cx="426391" cy="533354"/>
+            <a:off x="6743976" y="538527"/>
+            <a:ext cx="424851" cy="533354"/>
           </a:xfrm>
           <a:prstGeom prst="curvedConnector3">
             <a:avLst/>
@@ -6409,8 +6411,8 @@
         </p:nvCxnSpPr>
         <p:spPr>
           <a:xfrm>
-            <a:off x="4894718" y="1071111"/>
-            <a:ext cx="336511" cy="533354"/>
+            <a:off x="4896259" y="1071881"/>
+            <a:ext cx="334970" cy="533355"/>
           </a:xfrm>
           <a:prstGeom prst="curvedConnector3">
             <a:avLst>
@@ -6456,8 +6458,8 @@
         </p:nvCxnSpPr>
         <p:spPr>
           <a:xfrm flipV="1">
-            <a:off x="6285239" y="1071111"/>
-            <a:ext cx="266713" cy="533354"/>
+            <a:off x="6286779" y="1071881"/>
+            <a:ext cx="265173" cy="533355"/>
           </a:xfrm>
           <a:prstGeom prst="curvedConnector3">
             <a:avLst>
@@ -6503,7 +6505,7 @@
         <p:spPr>
           <a:xfrm>
             <a:off x="3630199" y="1071111"/>
-            <a:ext cx="1074035" cy="0"/>
+            <a:ext cx="1074036" cy="770"/>
           </a:xfrm>
           <a:prstGeom prst="line">
             <a:avLst/>
@@ -6561,7 +6563,7 @@
             <a:r>
               <a:rPr lang="en-US" dirty="0">
                 <a:solidFill>
-                  <a:schemeClr val="accent4"/>
+                  <a:schemeClr val="accent5"/>
                 </a:solidFill>
                 <a:latin typeface="Source Sans Pro" panose="020B0503030403020204" pitchFamily="34" charset="0"/>
                 <a:ea typeface="Source Sans Pro" panose="020B0503030403020204" pitchFamily="34" charset="0"/>
@@ -6603,9 +6605,7 @@
             <a:r>
               <a:rPr lang="en-US" dirty="0">
                 <a:solidFill>
-                  <a:schemeClr val="accent1">
-                    <a:lumMod val="50000"/>
-                  </a:schemeClr>
+                  <a:schemeClr val="accent4"/>
                 </a:solidFill>
                 <a:latin typeface="Source Sans Pro" panose="020B0503030403020204" pitchFamily="34" charset="0"/>
                 <a:ea typeface="Source Sans Pro" panose="020B0503030403020204" pitchFamily="34" charset="0"/>
@@ -6647,9 +6647,7 @@
             <a:r>
               <a:rPr lang="en-US" dirty="0">
                 <a:solidFill>
-                  <a:schemeClr val="accent1">
-                    <a:lumMod val="50000"/>
-                  </a:schemeClr>
+                  <a:schemeClr val="accent4"/>
                 </a:solidFill>
                 <a:latin typeface="Source Sans Pro" panose="020B0503030403020204" pitchFamily="34" charset="0"/>
                 <a:ea typeface="Source Sans Pro" panose="020B0503030403020204" pitchFamily="34" charset="0"/>
@@ -6691,7 +6689,7 @@
             <a:r>
               <a:rPr lang="en-US" dirty="0">
                 <a:solidFill>
-                  <a:schemeClr val="accent4"/>
+                  <a:schemeClr val="accent5"/>
                 </a:solidFill>
                 <a:latin typeface="Source Sans Pro" panose="020B0503030403020204" pitchFamily="34" charset="0"/>
                 <a:ea typeface="Source Sans Pro" panose="020B0503030403020204" pitchFamily="34" charset="0"/>
@@ -6710,13 +6708,74 @@
               </a:ext>
             </a:extLst>
           </p:cNvPr>
-          <p:cNvSpPr/>
+          <p:cNvSpPr>
+            <a:spLocks noChangeAspect="1"/>
+          </p:cNvSpPr>
           <p:nvPr/>
         </p:nvSpPr>
         <p:spPr>
           <a:xfrm>
             <a:off x="944354" y="442515"/>
-            <a:ext cx="190484" cy="190484"/>
+            <a:ext cx="192024" cy="192024"/>
+          </a:xfrm>
+          <a:prstGeom prst="ellipse">
+            <a:avLst/>
+          </a:prstGeom>
+          <a:ln/>
+        </p:spPr>
+        <p:style>
+          <a:lnRef idx="2">
+            <a:schemeClr val="accent3">
+              <a:shade val="15000"/>
+            </a:schemeClr>
+          </a:lnRef>
+          <a:fillRef idx="1">
+            <a:schemeClr val="accent3"/>
+          </a:fillRef>
+          <a:effectRef idx="0">
+            <a:schemeClr val="accent3"/>
+          </a:effectRef>
+          <a:fontRef idx="minor">
+            <a:schemeClr val="lt1"/>
+          </a:fontRef>
+        </p:style>
+        <p:txBody>
+          <a:bodyPr rtlCol="0" anchor="ctr"/>
+          <a:lstStyle/>
+          <a:p>
+            <a:pPr algn="ctr">
+              <a:lnSpc>
+                <a:spcPct val="95000"/>
+              </a:lnSpc>
+            </a:pPr>
+            <a:endParaRPr lang="en-US" b="1" dirty="0">
+              <a:solidFill>
+                <a:schemeClr val="tx2"/>
+              </a:solidFill>
+              <a:latin typeface="Source Sans Pro" panose="020B0503030403020204" pitchFamily="34" charset="0"/>
+              <a:ea typeface="Source Sans Pro" panose="020B0503030403020204" pitchFamily="34" charset="0"/>
+            </a:endParaRPr>
+          </a:p>
+        </p:txBody>
+      </p:sp>
+      <p:sp>
+        <p:nvSpPr>
+          <p:cNvPr id="4" name="Oval 3">
+            <a:extLst>
+              <a:ext uri="{FF2B5EF4-FFF2-40B4-BE49-F238E27FC236}">
+                <a16:creationId xmlns:a16="http://schemas.microsoft.com/office/drawing/2014/main" id="{83FBFBB3-9EB3-349B-1A00-A3BE7D6DFD08}"/>
+              </a:ext>
+            </a:extLst>
+          </p:cNvPr>
+          <p:cNvSpPr>
+            <a:spLocks noChangeAspect="1"/>
+          </p:cNvSpPr>
+          <p:nvPr/>
+        </p:nvSpPr>
+        <p:spPr>
+          <a:xfrm>
+            <a:off x="1591998" y="975869"/>
+            <a:ext cx="192024" cy="192024"/>
           </a:xfrm>
           <a:prstGeom prst="ellipse">
             <a:avLst/>
@@ -6760,20 +6819,22 @@
       </p:sp>
       <p:sp>
         <p:nvSpPr>
-          <p:cNvPr id="4" name="Oval 3">
+          <p:cNvPr id="5" name="Oval 4">
             <a:extLst>
               <a:ext uri="{FF2B5EF4-FFF2-40B4-BE49-F238E27FC236}">
-                <a16:creationId xmlns:a16="http://schemas.microsoft.com/office/drawing/2014/main" id="{83FBFBB3-9EB3-349B-1A00-A3BE7D6DFD08}"/>
+                <a16:creationId xmlns:a16="http://schemas.microsoft.com/office/drawing/2014/main" id="{C329FCC1-620A-BF81-BB90-F5F2D730DB64}"/>
               </a:ext>
             </a:extLst>
           </p:cNvPr>
-          <p:cNvSpPr/>
+          <p:cNvSpPr>
+            <a:spLocks noChangeAspect="1"/>
+          </p:cNvSpPr>
           <p:nvPr/>
         </p:nvSpPr>
         <p:spPr>
           <a:xfrm>
-            <a:off x="1591998" y="975869"/>
-            <a:ext cx="190484" cy="190484"/>
+            <a:off x="2118993" y="1509224"/>
+            <a:ext cx="192024" cy="192024"/>
           </a:xfrm>
           <a:prstGeom prst="ellipse">
             <a:avLst/>
@@ -6817,63 +6878,6 @@
       </p:sp>
       <p:sp>
         <p:nvSpPr>
-          <p:cNvPr id="5" name="Oval 4">
-            <a:extLst>
-              <a:ext uri="{FF2B5EF4-FFF2-40B4-BE49-F238E27FC236}">
-                <a16:creationId xmlns:a16="http://schemas.microsoft.com/office/drawing/2014/main" id="{C329FCC1-620A-BF81-BB90-F5F2D730DB64}"/>
-              </a:ext>
-            </a:extLst>
-          </p:cNvPr>
-          <p:cNvSpPr/>
-          <p:nvPr/>
-        </p:nvSpPr>
-        <p:spPr>
-          <a:xfrm>
-            <a:off x="2118993" y="1509224"/>
-            <a:ext cx="190484" cy="190484"/>
-          </a:xfrm>
-          <a:prstGeom prst="ellipse">
-            <a:avLst/>
-          </a:prstGeom>
-          <a:ln/>
-        </p:spPr>
-        <p:style>
-          <a:lnRef idx="2">
-            <a:schemeClr val="accent4">
-              <a:shade val="15000"/>
-            </a:schemeClr>
-          </a:lnRef>
-          <a:fillRef idx="1">
-            <a:schemeClr val="accent4"/>
-          </a:fillRef>
-          <a:effectRef idx="0">
-            <a:schemeClr val="accent4"/>
-          </a:effectRef>
-          <a:fontRef idx="minor">
-            <a:schemeClr val="lt1"/>
-          </a:fontRef>
-        </p:style>
-        <p:txBody>
-          <a:bodyPr rtlCol="0" anchor="ctr"/>
-          <a:lstStyle/>
-          <a:p>
-            <a:pPr algn="ctr">
-              <a:lnSpc>
-                <a:spcPct val="95000"/>
-              </a:lnSpc>
-            </a:pPr>
-            <a:endParaRPr lang="en-US" b="1" dirty="0">
-              <a:solidFill>
-                <a:schemeClr val="tx2"/>
-              </a:solidFill>
-              <a:latin typeface="Source Sans Pro" panose="020B0503030403020204" pitchFamily="34" charset="0"/>
-              <a:ea typeface="Source Sans Pro" panose="020B0503030403020204" pitchFamily="34" charset="0"/>
-            </a:endParaRPr>
-          </a:p>
-        </p:txBody>
-      </p:sp>
-      <p:sp>
-        <p:nvSpPr>
           <p:cNvPr id="6" name="Oval 5">
             <a:extLst>
               <a:ext uri="{FF2B5EF4-FFF2-40B4-BE49-F238E27FC236}">
@@ -6881,127 +6885,15 @@
               </a:ext>
             </a:extLst>
           </p:cNvPr>
-          <p:cNvSpPr/>
+          <p:cNvSpPr>
+            <a:spLocks noChangeAspect="1"/>
+          </p:cNvSpPr>
           <p:nvPr/>
         </p:nvSpPr>
         <p:spPr>
           <a:xfrm>
             <a:off x="2550756" y="1509224"/>
-            <a:ext cx="190484" cy="190484"/>
-          </a:xfrm>
-          <a:prstGeom prst="ellipse">
-            <a:avLst/>
-          </a:prstGeom>
-          <a:ln/>
-        </p:spPr>
-        <p:style>
-          <a:lnRef idx="2">
-            <a:schemeClr val="accent4">
-              <a:shade val="15000"/>
-            </a:schemeClr>
-          </a:lnRef>
-          <a:fillRef idx="1">
-            <a:schemeClr val="accent4"/>
-          </a:fillRef>
-          <a:effectRef idx="0">
-            <a:schemeClr val="accent4"/>
-          </a:effectRef>
-          <a:fontRef idx="minor">
-            <a:schemeClr val="lt1"/>
-          </a:fontRef>
-        </p:style>
-        <p:txBody>
-          <a:bodyPr rtlCol="0" anchor="ctr"/>
-          <a:lstStyle/>
-          <a:p>
-            <a:pPr algn="ctr">
-              <a:lnSpc>
-                <a:spcPct val="95000"/>
-              </a:lnSpc>
-            </a:pPr>
-            <a:endParaRPr lang="en-US" b="1" dirty="0">
-              <a:solidFill>
-                <a:schemeClr val="tx2"/>
-              </a:solidFill>
-              <a:latin typeface="Source Sans Pro" panose="020B0503030403020204" pitchFamily="34" charset="0"/>
-              <a:ea typeface="Source Sans Pro" panose="020B0503030403020204" pitchFamily="34" charset="0"/>
-            </a:endParaRPr>
-          </a:p>
-        </p:txBody>
-      </p:sp>
-      <p:sp>
-        <p:nvSpPr>
-          <p:cNvPr id="7" name="Oval 6">
-            <a:extLst>
-              <a:ext uri="{FF2B5EF4-FFF2-40B4-BE49-F238E27FC236}">
-                <a16:creationId xmlns:a16="http://schemas.microsoft.com/office/drawing/2014/main" id="{2190A2A8-7F7D-398B-2698-396A339B3EDA}"/>
-              </a:ext>
-            </a:extLst>
-          </p:cNvPr>
-          <p:cNvSpPr/>
-          <p:nvPr/>
-        </p:nvSpPr>
-        <p:spPr>
-          <a:xfrm>
-            <a:off x="2982519" y="1509224"/>
-            <a:ext cx="190484" cy="190484"/>
-          </a:xfrm>
-          <a:prstGeom prst="ellipse">
-            <a:avLst/>
-          </a:prstGeom>
-          <a:ln/>
-        </p:spPr>
-        <p:style>
-          <a:lnRef idx="2">
-            <a:schemeClr val="accent4">
-              <a:shade val="15000"/>
-            </a:schemeClr>
-          </a:lnRef>
-          <a:fillRef idx="1">
-            <a:schemeClr val="accent4"/>
-          </a:fillRef>
-          <a:effectRef idx="0">
-            <a:schemeClr val="accent4"/>
-          </a:effectRef>
-          <a:fontRef idx="minor">
-            <a:schemeClr val="lt1"/>
-          </a:fontRef>
-        </p:style>
-        <p:txBody>
-          <a:bodyPr rtlCol="0" anchor="ctr"/>
-          <a:lstStyle/>
-          <a:p>
-            <a:pPr algn="ctr">
-              <a:lnSpc>
-                <a:spcPct val="95000"/>
-              </a:lnSpc>
-            </a:pPr>
-            <a:endParaRPr lang="en-US" b="1" dirty="0">
-              <a:solidFill>
-                <a:schemeClr val="tx2"/>
-              </a:solidFill>
-              <a:latin typeface="Source Sans Pro" panose="020B0503030403020204" pitchFamily="34" charset="0"/>
-              <a:ea typeface="Source Sans Pro" panose="020B0503030403020204" pitchFamily="34" charset="0"/>
-            </a:endParaRPr>
-          </a:p>
-        </p:txBody>
-      </p:sp>
-      <p:sp>
-        <p:nvSpPr>
-          <p:cNvPr id="8" name="Oval 7">
-            <a:extLst>
-              <a:ext uri="{FF2B5EF4-FFF2-40B4-BE49-F238E27FC236}">
-                <a16:creationId xmlns:a16="http://schemas.microsoft.com/office/drawing/2014/main" id="{8E78FF2B-3A8E-68B0-FDB7-9F5AED01A85B}"/>
-              </a:ext>
-            </a:extLst>
-          </p:cNvPr>
-          <p:cNvSpPr/>
-          <p:nvPr/>
-        </p:nvSpPr>
-        <p:spPr>
-          <a:xfrm>
-            <a:off x="3439716" y="975869"/>
-            <a:ext cx="190484" cy="190484"/>
+            <a:ext cx="192024" cy="192024"/>
           </a:xfrm>
           <a:prstGeom prst="ellipse">
             <a:avLst/>
@@ -7045,20 +6937,81 @@
       </p:sp>
       <p:sp>
         <p:nvSpPr>
-          <p:cNvPr id="19" name="Oval 18">
+          <p:cNvPr id="7" name="Oval 6">
             <a:extLst>
               <a:ext uri="{FF2B5EF4-FFF2-40B4-BE49-F238E27FC236}">
-                <a16:creationId xmlns:a16="http://schemas.microsoft.com/office/drawing/2014/main" id="{59B0635B-B598-12AB-F78A-13583EEEBF61}"/>
+                <a16:creationId xmlns:a16="http://schemas.microsoft.com/office/drawing/2014/main" id="{2190A2A8-7F7D-398B-2698-396A339B3EDA}"/>
               </a:ext>
             </a:extLst>
           </p:cNvPr>
-          <p:cNvSpPr/>
+          <p:cNvSpPr>
+            <a:spLocks noChangeAspect="1"/>
+          </p:cNvSpPr>
           <p:nvPr/>
         </p:nvSpPr>
         <p:spPr>
           <a:xfrm>
-            <a:off x="7168827" y="442515"/>
-            <a:ext cx="190484" cy="190484"/>
+            <a:off x="2982519" y="1509224"/>
+            <a:ext cx="192024" cy="192024"/>
+          </a:xfrm>
+          <a:prstGeom prst="ellipse">
+            <a:avLst/>
+          </a:prstGeom>
+          <a:ln/>
+        </p:spPr>
+        <p:style>
+          <a:lnRef idx="2">
+            <a:schemeClr val="accent5">
+              <a:shade val="15000"/>
+            </a:schemeClr>
+          </a:lnRef>
+          <a:fillRef idx="1">
+            <a:schemeClr val="accent5"/>
+          </a:fillRef>
+          <a:effectRef idx="0">
+            <a:schemeClr val="accent5"/>
+          </a:effectRef>
+          <a:fontRef idx="minor">
+            <a:schemeClr val="lt1"/>
+          </a:fontRef>
+        </p:style>
+        <p:txBody>
+          <a:bodyPr rtlCol="0" anchor="ctr"/>
+          <a:lstStyle/>
+          <a:p>
+            <a:pPr algn="ctr">
+              <a:lnSpc>
+                <a:spcPct val="95000"/>
+              </a:lnSpc>
+            </a:pPr>
+            <a:endParaRPr lang="en-US" b="1" dirty="0">
+              <a:solidFill>
+                <a:schemeClr val="tx2"/>
+              </a:solidFill>
+              <a:latin typeface="Source Sans Pro" panose="020B0503030403020204" pitchFamily="34" charset="0"/>
+              <a:ea typeface="Source Sans Pro" panose="020B0503030403020204" pitchFamily="34" charset="0"/>
+            </a:endParaRPr>
+          </a:p>
+        </p:txBody>
+      </p:sp>
+      <p:sp>
+        <p:nvSpPr>
+          <p:cNvPr id="8" name="Oval 7">
+            <a:extLst>
+              <a:ext uri="{FF2B5EF4-FFF2-40B4-BE49-F238E27FC236}">
+                <a16:creationId xmlns:a16="http://schemas.microsoft.com/office/drawing/2014/main" id="{8E78FF2B-3A8E-68B0-FDB7-9F5AED01A85B}"/>
+              </a:ext>
+            </a:extLst>
+          </p:cNvPr>
+          <p:cNvSpPr>
+            <a:spLocks noChangeAspect="1"/>
+          </p:cNvSpPr>
+          <p:nvPr/>
+        </p:nvSpPr>
+        <p:spPr>
+          <a:xfrm>
+            <a:off x="3439716" y="975869"/>
+            <a:ext cx="192024" cy="192024"/>
           </a:xfrm>
           <a:prstGeom prst="ellipse">
             <a:avLst/>
@@ -7102,6 +7055,65 @@
       </p:sp>
       <p:sp>
         <p:nvSpPr>
+          <p:cNvPr id="19" name="Oval 18">
+            <a:extLst>
+              <a:ext uri="{FF2B5EF4-FFF2-40B4-BE49-F238E27FC236}">
+                <a16:creationId xmlns:a16="http://schemas.microsoft.com/office/drawing/2014/main" id="{59B0635B-B598-12AB-F78A-13583EEEBF61}"/>
+              </a:ext>
+            </a:extLst>
+          </p:cNvPr>
+          <p:cNvSpPr>
+            <a:spLocks noChangeAspect="1"/>
+          </p:cNvSpPr>
+          <p:nvPr/>
+        </p:nvSpPr>
+        <p:spPr>
+          <a:xfrm>
+            <a:off x="7168827" y="442515"/>
+            <a:ext cx="192024" cy="192024"/>
+          </a:xfrm>
+          <a:prstGeom prst="ellipse">
+            <a:avLst/>
+          </a:prstGeom>
+          <a:ln/>
+        </p:spPr>
+        <p:style>
+          <a:lnRef idx="2">
+            <a:schemeClr val="accent3">
+              <a:shade val="15000"/>
+            </a:schemeClr>
+          </a:lnRef>
+          <a:fillRef idx="1">
+            <a:schemeClr val="accent3"/>
+          </a:fillRef>
+          <a:effectRef idx="0">
+            <a:schemeClr val="accent3"/>
+          </a:effectRef>
+          <a:fontRef idx="minor">
+            <a:schemeClr val="lt1"/>
+          </a:fontRef>
+        </p:style>
+        <p:txBody>
+          <a:bodyPr rtlCol="0" anchor="ctr"/>
+          <a:lstStyle/>
+          <a:p>
+            <a:pPr algn="ctr">
+              <a:lnSpc>
+                <a:spcPct val="95000"/>
+              </a:lnSpc>
+            </a:pPr>
+            <a:endParaRPr lang="en-US" b="1" dirty="0">
+              <a:solidFill>
+                <a:schemeClr val="tx2"/>
+              </a:solidFill>
+              <a:latin typeface="Source Sans Pro" panose="020B0503030403020204" pitchFamily="34" charset="0"/>
+              <a:ea typeface="Source Sans Pro" panose="020B0503030403020204" pitchFamily="34" charset="0"/>
+            </a:endParaRPr>
+          </a:p>
+        </p:txBody>
+      </p:sp>
+      <p:sp>
+        <p:nvSpPr>
           <p:cNvPr id="20" name="Oval 19">
             <a:extLst>
               <a:ext uri="{FF2B5EF4-FFF2-40B4-BE49-F238E27FC236}">
@@ -7109,13 +7121,74 @@
               </a:ext>
             </a:extLst>
           </p:cNvPr>
-          <p:cNvSpPr/>
+          <p:cNvSpPr>
+            <a:spLocks noChangeAspect="1"/>
+          </p:cNvSpPr>
           <p:nvPr/>
         </p:nvSpPr>
         <p:spPr>
           <a:xfrm>
             <a:off x="4704235" y="975869"/>
-            <a:ext cx="190484" cy="190484"/>
+            <a:ext cx="192024" cy="192024"/>
+          </a:xfrm>
+          <a:prstGeom prst="ellipse">
+            <a:avLst/>
+          </a:prstGeom>
+          <a:ln/>
+        </p:spPr>
+        <p:style>
+          <a:lnRef idx="2">
+            <a:schemeClr val="accent1">
+              <a:shade val="15000"/>
+            </a:schemeClr>
+          </a:lnRef>
+          <a:fillRef idx="1">
+            <a:schemeClr val="accent1"/>
+          </a:fillRef>
+          <a:effectRef idx="0">
+            <a:schemeClr val="accent1"/>
+          </a:effectRef>
+          <a:fontRef idx="minor">
+            <a:schemeClr val="lt1"/>
+          </a:fontRef>
+        </p:style>
+        <p:txBody>
+          <a:bodyPr rtlCol="0" anchor="ctr"/>
+          <a:lstStyle/>
+          <a:p>
+            <a:pPr algn="ctr">
+              <a:lnSpc>
+                <a:spcPct val="95000"/>
+              </a:lnSpc>
+            </a:pPr>
+            <a:endParaRPr lang="en-US" b="1" dirty="0">
+              <a:solidFill>
+                <a:schemeClr val="tx2"/>
+              </a:solidFill>
+              <a:latin typeface="Source Sans Pro" panose="020B0503030403020204" pitchFamily="34" charset="0"/>
+              <a:ea typeface="Source Sans Pro" panose="020B0503030403020204" pitchFamily="34" charset="0"/>
+            </a:endParaRPr>
+          </a:p>
+        </p:txBody>
+      </p:sp>
+      <p:sp>
+        <p:nvSpPr>
+          <p:cNvPr id="21" name="Oval 20">
+            <a:extLst>
+              <a:ext uri="{FF2B5EF4-FFF2-40B4-BE49-F238E27FC236}">
+                <a16:creationId xmlns:a16="http://schemas.microsoft.com/office/drawing/2014/main" id="{0963B28E-CDD0-88D5-D47E-CC2D110C0C81}"/>
+              </a:ext>
+            </a:extLst>
+          </p:cNvPr>
+          <p:cNvSpPr>
+            <a:spLocks noChangeAspect="1"/>
+          </p:cNvSpPr>
+          <p:nvPr/>
+        </p:nvSpPr>
+        <p:spPr>
+          <a:xfrm>
+            <a:off x="5231229" y="1509224"/>
+            <a:ext cx="192024" cy="192024"/>
           </a:xfrm>
           <a:prstGeom prst="ellipse">
             <a:avLst/>
@@ -7159,20 +7232,22 @@
       </p:sp>
       <p:sp>
         <p:nvSpPr>
-          <p:cNvPr id="21" name="Oval 20">
+          <p:cNvPr id="22" name="Oval 21">
             <a:extLst>
               <a:ext uri="{FF2B5EF4-FFF2-40B4-BE49-F238E27FC236}">
-                <a16:creationId xmlns:a16="http://schemas.microsoft.com/office/drawing/2014/main" id="{0963B28E-CDD0-88D5-D47E-CC2D110C0C81}"/>
+                <a16:creationId xmlns:a16="http://schemas.microsoft.com/office/drawing/2014/main" id="{433FD074-A43F-915F-0E2A-F795137AB13D}"/>
               </a:ext>
             </a:extLst>
           </p:cNvPr>
-          <p:cNvSpPr/>
+          <p:cNvSpPr>
+            <a:spLocks noChangeAspect="1"/>
+          </p:cNvSpPr>
           <p:nvPr/>
         </p:nvSpPr>
         <p:spPr>
           <a:xfrm>
-            <a:off x="5231229" y="1509224"/>
-            <a:ext cx="190484" cy="190484"/>
+            <a:off x="5662992" y="1509224"/>
+            <a:ext cx="192024" cy="192024"/>
           </a:xfrm>
           <a:prstGeom prst="ellipse">
             <a:avLst/>
@@ -7181,15 +7256,15 @@
         </p:spPr>
         <p:style>
           <a:lnRef idx="2">
-            <a:schemeClr val="accent4">
+            <a:schemeClr val="accent5">
               <a:shade val="15000"/>
             </a:schemeClr>
           </a:lnRef>
           <a:fillRef idx="1">
-            <a:schemeClr val="accent4"/>
+            <a:schemeClr val="accent5"/>
           </a:fillRef>
           <a:effectRef idx="0">
-            <a:schemeClr val="accent4"/>
+            <a:schemeClr val="accent5"/>
           </a:effectRef>
           <a:fontRef idx="minor">
             <a:schemeClr val="lt1"/>
@@ -7216,20 +7291,22 @@
       </p:sp>
       <p:sp>
         <p:nvSpPr>
-          <p:cNvPr id="22" name="Oval 21">
+          <p:cNvPr id="23" name="Oval 22">
             <a:extLst>
               <a:ext uri="{FF2B5EF4-FFF2-40B4-BE49-F238E27FC236}">
-                <a16:creationId xmlns:a16="http://schemas.microsoft.com/office/drawing/2014/main" id="{433FD074-A43F-915F-0E2A-F795137AB13D}"/>
+                <a16:creationId xmlns:a16="http://schemas.microsoft.com/office/drawing/2014/main" id="{7AA43E6F-8721-2431-5D8B-ABE6371ADAAD}"/>
               </a:ext>
             </a:extLst>
           </p:cNvPr>
-          <p:cNvSpPr/>
+          <p:cNvSpPr>
+            <a:spLocks noChangeAspect="1"/>
+          </p:cNvSpPr>
           <p:nvPr/>
         </p:nvSpPr>
         <p:spPr>
           <a:xfrm>
-            <a:off x="5662992" y="1509224"/>
-            <a:ext cx="190484" cy="190484"/>
+            <a:off x="6094755" y="1509224"/>
+            <a:ext cx="192024" cy="192024"/>
           </a:xfrm>
           <a:prstGeom prst="ellipse">
             <a:avLst/>
@@ -7238,15 +7315,15 @@
         </p:spPr>
         <p:style>
           <a:lnRef idx="2">
-            <a:schemeClr val="accent4">
+            <a:schemeClr val="accent5">
               <a:shade val="15000"/>
             </a:schemeClr>
           </a:lnRef>
           <a:fillRef idx="1">
-            <a:schemeClr val="accent4"/>
+            <a:schemeClr val="accent5"/>
           </a:fillRef>
           <a:effectRef idx="0">
-            <a:schemeClr val="accent4"/>
+            <a:schemeClr val="accent5"/>
           </a:effectRef>
           <a:fontRef idx="minor">
             <a:schemeClr val="lt1"/>
@@ -7273,63 +7350,6 @@
       </p:sp>
       <p:sp>
         <p:nvSpPr>
-          <p:cNvPr id="23" name="Oval 22">
-            <a:extLst>
-              <a:ext uri="{FF2B5EF4-FFF2-40B4-BE49-F238E27FC236}">
-                <a16:creationId xmlns:a16="http://schemas.microsoft.com/office/drawing/2014/main" id="{7AA43E6F-8721-2431-5D8B-ABE6371ADAAD}"/>
-              </a:ext>
-            </a:extLst>
-          </p:cNvPr>
-          <p:cNvSpPr/>
-          <p:nvPr/>
-        </p:nvSpPr>
-        <p:spPr>
-          <a:xfrm>
-            <a:off x="6094755" y="1509224"/>
-            <a:ext cx="190484" cy="190484"/>
-          </a:xfrm>
-          <a:prstGeom prst="ellipse">
-            <a:avLst/>
-          </a:prstGeom>
-          <a:ln/>
-        </p:spPr>
-        <p:style>
-          <a:lnRef idx="2">
-            <a:schemeClr val="accent4">
-              <a:shade val="15000"/>
-            </a:schemeClr>
-          </a:lnRef>
-          <a:fillRef idx="1">
-            <a:schemeClr val="accent4"/>
-          </a:fillRef>
-          <a:effectRef idx="0">
-            <a:schemeClr val="accent4"/>
-          </a:effectRef>
-          <a:fontRef idx="minor">
-            <a:schemeClr val="lt1"/>
-          </a:fontRef>
-        </p:style>
-        <p:txBody>
-          <a:bodyPr rtlCol="0" anchor="ctr"/>
-          <a:lstStyle/>
-          <a:p>
-            <a:pPr algn="ctr">
-              <a:lnSpc>
-                <a:spcPct val="95000"/>
-              </a:lnSpc>
-            </a:pPr>
-            <a:endParaRPr lang="en-US" b="1" dirty="0">
-              <a:solidFill>
-                <a:schemeClr val="tx2"/>
-              </a:solidFill>
-              <a:latin typeface="Source Sans Pro" panose="020B0503030403020204" pitchFamily="34" charset="0"/>
-              <a:ea typeface="Source Sans Pro" panose="020B0503030403020204" pitchFamily="34" charset="0"/>
-            </a:endParaRPr>
-          </a:p>
-        </p:txBody>
-      </p:sp>
-      <p:sp>
-        <p:nvSpPr>
           <p:cNvPr id="24" name="Oval 23">
             <a:extLst>
               <a:ext uri="{FF2B5EF4-FFF2-40B4-BE49-F238E27FC236}">
@@ -7337,13 +7357,15 @@
               </a:ext>
             </a:extLst>
           </p:cNvPr>
-          <p:cNvSpPr/>
+          <p:cNvSpPr>
+            <a:spLocks noChangeAspect="1"/>
+          </p:cNvSpPr>
           <p:nvPr/>
         </p:nvSpPr>
         <p:spPr>
           <a:xfrm>
             <a:off x="6551952" y="975869"/>
-            <a:ext cx="190484" cy="190484"/>
+            <a:ext cx="192024" cy="192024"/>
           </a:xfrm>
           <a:prstGeom prst="ellipse">
             <a:avLst/>
@@ -7352,15 +7374,15 @@
         </p:spPr>
         <p:style>
           <a:lnRef idx="2">
-            <a:schemeClr val="accent5">
+            <a:schemeClr val="accent1">
               <a:shade val="15000"/>
             </a:schemeClr>
           </a:lnRef>
           <a:fillRef idx="1">
-            <a:schemeClr val="accent5"/>
+            <a:schemeClr val="accent1"/>
           </a:fillRef>
           <a:effectRef idx="0">
-            <a:schemeClr val="accent5"/>
+            <a:schemeClr val="accent1"/>
           </a:effectRef>
           <a:fontRef idx="minor">
             <a:schemeClr val="lt1"/>

</xml_diff>